<commit_message>
Aplica no roteiro e no deck a verificacao do homonimo AsiaCCS
Complementa o commit anterior, em que as edicoes do roteiro falado e do
gerador do deck falharam por incompatibilidade de texto e so o protocolo
foi atualizado.

O roteiro passa a dizer em voz alta que a posicao 19 da mesma lista e a
AsiaCCS, evento diferente com h5 41, e que a identidade do veiculo foi
confirmada clicando no indice para ver os artigos que o compoem. O slide 8
traz a mesma ressalva numa linha.

Co-Authored-By: Claude Opus 5 <noreply@anthropic.com>
Claude-Session: https://claude.ai/code/session_01Sfh8JG34eEyQqGRvuKsFRT
</commit_message>
<xml_diff>
--- a/seminario/seminario-analise-de-artigo.pptx
+++ b/seminario/seminario-analise-de-artigo.pptx
@@ -10287,11 +10287,11 @@
         <p:spPr>
           <a:xfrm>
             <a:off x="502920" y="932688"/>
-            <a:ext cx="3954780" cy="1481328"/>
+            <a:ext cx="3954780" cy="1691640"/>
           </a:xfrm>
           <a:prstGeom prst="roundRect">
             <a:avLst>
-              <a:gd name="adj" fmla="val 3704"/>
+              <a:gd name="adj" fmla="val 3243"/>
             </a:avLst>
           </a:prstGeom>
           <a:solidFill>
@@ -10353,7 +10353,7 @@
         <p:spPr>
           <a:xfrm>
             <a:off x="685800" y="1371600"/>
-            <a:ext cx="3589020" cy="896112"/>
+            <a:ext cx="3589020" cy="1106424"/>
           </a:xfrm>
           <a:prstGeom prst="rect">
             <a:avLst/>
@@ -10400,7 +10400,7 @@
                 <a:ea typeface="Calibri" pitchFamily="34" charset="-122"/>
                 <a:cs typeface="Calibri" pitchFamily="34" charset="-120"/>
               </a:rPr>
-              <a:t>2 · Qualis = A1   (ver o limiar ao lado)</a:t>
+              <a:t>     (posição 19 = AsiaCCS, h5 41 — outro evento; conferido)</a:t>
             </a:r>
             <a:endParaRPr lang="en-US" sz="1150" dirty="0"/>
           </a:p>
@@ -10420,6 +10420,26 @@
                 <a:ea typeface="Calibri" pitchFamily="34" charset="-122"/>
                 <a:cs typeface="Calibri" pitchFamily="34" charset="-120"/>
               </a:rPr>
+              <a:t>2 · Qualis = A1   (ver o limiar ao lado)</a:t>
+            </a:r>
+            <a:endParaRPr lang="en-US" sz="1150" dirty="0"/>
+          </a:p>
+          <a:p>
+            <a:pPr indent="0" marL="0">
+              <a:spcAft>
+                <a:spcPts val="400"/>
+              </a:spcAft>
+              <a:buNone/>
+            </a:pPr>
+            <a:r>
+              <a:rPr lang="en-US" sz="1150" dirty="0">
+                <a:solidFill>
+                  <a:srgbClr val="5A6472"/>
+                </a:solidFill>
+                <a:latin typeface="Calibri" pitchFamily="34" charset="0"/>
+                <a:ea typeface="Calibri" pitchFamily="34" charset="-122"/>
+                <a:cs typeface="Calibri" pitchFamily="34" charset="-120"/>
+              </a:rPr>
               <a:t>3 · CORE = A*   ICORE2026</a:t>
             </a:r>
             <a:endParaRPr lang="en-US" sz="1150" dirty="0"/>
@@ -10434,12 +10454,12 @@
         </p:nvSpPr>
         <p:spPr>
           <a:xfrm>
-            <a:off x="502920" y="2560320"/>
-            <a:ext cx="3954780" cy="1874520"/>
+            <a:off x="502920" y="2761488"/>
+            <a:ext cx="3954780" cy="1673352"/>
           </a:xfrm>
           <a:prstGeom prst="roundRect">
             <a:avLst>
-              <a:gd name="adj" fmla="val 2927"/>
+              <a:gd name="adj" fmla="val 3279"/>
             </a:avLst>
           </a:prstGeom>
           <a:solidFill>
@@ -10461,7 +10481,7 @@
         </p:nvSpPr>
         <p:spPr>
           <a:xfrm>
-            <a:off x="685800" y="2688336"/>
+            <a:off x="685800" y="2889504"/>
             <a:ext cx="3589020" cy="274320"/>
           </a:xfrm>
           <a:prstGeom prst="rect">
@@ -10500,8 +10520,8 @@
         </p:nvSpPr>
         <p:spPr>
           <a:xfrm>
-            <a:off x="685800" y="2999232"/>
-            <a:ext cx="3589020" cy="1289304"/>
+            <a:off x="685800" y="3200400"/>
+            <a:ext cx="3589020" cy="1088136"/>
           </a:xfrm>
           <a:prstGeom prst="rect">
             <a:avLst/>

</xml_diff>